<commit_message>
PlayBooks: in-play list wording
Co-Authored-By: Claude Fable 5.1 <noreply@anthropic.com>
</commit_message>
<xml_diff>
--- a/docs/playbook/PlayBook-Fashionably-Late.pptx
+++ b/docs/playbook/PlayBook-Fashionably-Late.pptx
@@ -3349,7 +3349,7 @@
                 </a:solidFill>
                 <a:latin typeface="Lato"/>
               </a:rPr>
-              <a:t> single stocks from the gameplan; no ETFs or commodities.</a:t>
+              <a:t> single stocks from the morning in-play list; no ETFs or commodities.</a:t>
             </a:r>
           </a:p>
           <a:p>
@@ -5253,7 +5253,7 @@
                           </a:solidFill>
                           <a:latin typeface="Lato"/>
                         </a:rPr>
-                        <a:t>Gameplan names only; no catalyst or news scoring yet.</a:t>
+                        <a:t>In-play names only; no catalyst or news scoring yet.</a:t>
                       </a:r>
                     </a:p>
                   </a:txBody>

</xml_diff>